<commit_message>
Update PowerPoint for song #214 in FUBC - Українські
</commit_message>
<xml_diff>
--- a/fubc-ua/214-Браття, радійте (Пісні Спасенних №212).pptx
+++ b/fubc-ua/214-Браття, радійте (Пісні Спасенних №212).pptx
@@ -1469,7 +1469,7 @@
         </p:nvSpPr>
         <p:spPr>
           <a:xfrm>
-            <a:off x="2783510" y="2755392"/>
+            <a:off x="2882570" y="2755392"/>
             <a:ext cx="0" cy="2971800"/>
           </a:xfrm>
           <a:prstGeom prst="line">
@@ -1492,7 +1492,7 @@
         </p:nvSpPr>
         <p:spPr>
           <a:xfrm>
-            <a:off x="9414586" y="2755392"/>
+            <a:off x="9315526" y="2755392"/>
             <a:ext cx="0" cy="2971800"/>
           </a:xfrm>
           <a:prstGeom prst="line">
@@ -1515,8 +1515,8 @@
         </p:nvSpPr>
         <p:spPr>
           <a:xfrm>
-            <a:off x="9546666" y="4010152"/>
-            <a:ext cx="792480" cy="462280"/>
+            <a:off x="9414586" y="3921252"/>
+            <a:ext cx="1097280" cy="640080"/>
           </a:xfrm>
           <a:prstGeom prst="rect">
             <a:avLst/>
@@ -1532,9 +1532,9 @@
               <a:buNone/>
             </a:pPr>
             <a:r>
-              <a:rPr lang="en-US" sz="2600" b="1" dirty="0">
-                <a:solidFill>
-                  <a:srgbClr val="8A8A8A"/>
+              <a:rPr lang="en-US" sz="3600" b="1" dirty="0">
+                <a:solidFill>
+                  <a:srgbClr val="BBBBBB"/>
                 </a:solidFill>
                 <a:latin typeface="Arial" pitchFamily="34" charset="0"/>
                 <a:ea typeface="Arial" pitchFamily="34" charset="-122"/>
@@ -1542,7 +1542,7 @@
               </a:rPr>
               <a:t>×2</a:t>
             </a:r>
-            <a:endParaRPr lang="en-US" sz="2600" dirty="0"/>
+            <a:endParaRPr lang="en-US" sz="3600" dirty="0"/>
           </a:p>
         </p:txBody>
       </p:sp>
@@ -1748,7 +1748,7 @@
         </p:nvSpPr>
         <p:spPr>
           <a:xfrm>
-            <a:off x="2921203" y="3151632"/>
+            <a:off x="3020263" y="3151632"/>
             <a:ext cx="0" cy="2971800"/>
           </a:xfrm>
           <a:prstGeom prst="line">
@@ -1771,7 +1771,7 @@
         </p:nvSpPr>
         <p:spPr>
           <a:xfrm>
-            <a:off x="9276893" y="3151632"/>
+            <a:off x="9177833" y="3151632"/>
             <a:ext cx="0" cy="2971800"/>
           </a:xfrm>
           <a:prstGeom prst="line">
@@ -1794,8 +1794,8 @@
         </p:nvSpPr>
         <p:spPr>
           <a:xfrm>
-            <a:off x="9408973" y="4406392"/>
-            <a:ext cx="792480" cy="462280"/>
+            <a:off x="9276893" y="4317492"/>
+            <a:ext cx="1097280" cy="640080"/>
           </a:xfrm>
           <a:prstGeom prst="rect">
             <a:avLst/>
@@ -1811,9 +1811,9 @@
               <a:buNone/>
             </a:pPr>
             <a:r>
-              <a:rPr lang="en-US" sz="2600" b="1" dirty="0">
-                <a:solidFill>
-                  <a:srgbClr val="8A8A8A"/>
+              <a:rPr lang="en-US" sz="3600" b="1" dirty="0">
+                <a:solidFill>
+                  <a:srgbClr val="BBBBBB"/>
                 </a:solidFill>
                 <a:latin typeface="Arial" pitchFamily="34" charset="0"/>
                 <a:ea typeface="Arial" pitchFamily="34" charset="-122"/>
@@ -1821,7 +1821,7 @@
               </a:rPr>
               <a:t>×2</a:t>
             </a:r>
-            <a:endParaRPr lang="en-US" sz="2600" dirty="0"/>
+            <a:endParaRPr lang="en-US" sz="3600" dirty="0"/>
           </a:p>
         </p:txBody>
       </p:sp>
@@ -2027,7 +2027,7 @@
         </p:nvSpPr>
         <p:spPr>
           <a:xfrm>
-            <a:off x="2733319" y="3151632"/>
+            <a:off x="2832379" y="3151632"/>
             <a:ext cx="0" cy="2971800"/>
           </a:xfrm>
           <a:prstGeom prst="line">
@@ -2050,7 +2050,7 @@
         </p:nvSpPr>
         <p:spPr>
           <a:xfrm>
-            <a:off x="9464777" y="3151632"/>
+            <a:off x="9365717" y="3151632"/>
             <a:ext cx="0" cy="2971800"/>
           </a:xfrm>
           <a:prstGeom prst="line">
@@ -2073,8 +2073,8 @@
         </p:nvSpPr>
         <p:spPr>
           <a:xfrm>
-            <a:off x="9596857" y="4406392"/>
-            <a:ext cx="792480" cy="462280"/>
+            <a:off x="9464777" y="4317492"/>
+            <a:ext cx="1097280" cy="640080"/>
           </a:xfrm>
           <a:prstGeom prst="rect">
             <a:avLst/>
@@ -2090,9 +2090,9 @@
               <a:buNone/>
             </a:pPr>
             <a:r>
-              <a:rPr lang="en-US" sz="2600" b="1" dirty="0">
-                <a:solidFill>
-                  <a:srgbClr val="8A8A8A"/>
+              <a:rPr lang="en-US" sz="3600" b="1" dirty="0">
+                <a:solidFill>
+                  <a:srgbClr val="BBBBBB"/>
                 </a:solidFill>
                 <a:latin typeface="Arial" pitchFamily="34" charset="0"/>
                 <a:ea typeface="Arial" pitchFamily="34" charset="-122"/>
@@ -2100,7 +2100,7 @@
               </a:rPr>
               <a:t>×2</a:t>
             </a:r>
-            <a:endParaRPr lang="en-US" sz="2600" dirty="0"/>
+            <a:endParaRPr lang="en-US" sz="3600" dirty="0"/>
           </a:p>
         </p:txBody>
       </p:sp>

</xml_diff>